<commit_message>
Treat the work as new: remove references to previous work; Arial GOST deck
- Removed all mentions of the previous work and its reference; renumbered citations
- GOST deck uses Arial 24/32 pt per common presentation guidelines
- Table and caption fixes from the re-check

Co-Authored-By: Claude Opus 5.5 <noreply@anthropic.com>
Claude-Session: https://claude.ai/code/session_01CdksXxatJkGzkSNxfzYT6S
</commit_message>
<xml_diff>
--- a/Доклад_красивый.pptx
+++ b/Доклад_красивый.pptx
@@ -1230,7 +1230,7 @@
             <a:r>
               <a:rPr lang="en-US" dirty="0"/>
               <a:t>NIKITA:
-Why is this topic important? At cruising level, radiation is 11 to 22 times higher than on the ground. Since 1990, international experts have treated this exposure as part of the job. Special sanitary rules for aircrew were cancelled in 2021 and 2025. And with 900 flight hours a year, the dose can reach about 3.6 millisieverts. That is more than 70 percent of the limit. So our question is simple: does the law really protect each crew member?</a:t>
+Why is this topic important? At cruising level, radiation is 11 to 22 times higher than on the ground. Since 1990, international experts have treated this exposure as part of the job. We checked this with our own measurements on board. Special sanitary rules for aircrew were cancelled in 2021 and 2025. And with 900 flight hours a year, the dose can reach about 3.6 millisieverts. That is more than 70 percent of the limit. So our question is simple: does the law really protect each crew member?</a:t>
             </a:r>
             <a:endParaRPr lang="en-US" dirty="0"/>
           </a:p>
@@ -1408,7 +1408,7 @@
             <a:r>
               <a:rPr lang="en-US" dirty="0"/>
               <a:t>NIKITA:
-First, a few facts from my previous work. I measured radiation on two flights with a home-made Geiger counter. Near the ground the device showed about 8 to 15 microroentgens per hour. At cruising level it showed 170 to 184. But a Geiger counter does not see neutrons, and neutrons give a large part of the dose. So the real annual dose must be calculated, not just measured.</a:t>
+First, our measurements. We measured radiation on two flights with a home-made Geiger counter. Near the ground the device showed about 8 to 15 microroentgens per hour. At cruising level it showed 170 to 184. But a Geiger counter does not see neutrons, and neutrons give a large part of the dose. So the real annual dose must be calculated, not just measured.</a:t>
             </a:r>
             <a:endParaRPr lang="en-US" dirty="0"/>
           </a:p>
@@ -2013,7 +2013,7 @@
         </p:nvSpPr>
         <p:spPr>
           <a:xfrm>
-            <a:off x="1325880" y="1207008"/>
+            <a:off x="1325880" y="1115568"/>
             <a:ext cx="10317175" cy="0"/>
           </a:xfrm>
           <a:prstGeom prst="line">
@@ -2215,7 +2215,7 @@
         </p:nvSpPr>
         <p:spPr>
           <a:xfrm>
-            <a:off x="1325880" y="1207008"/>
+            <a:off x="1325880" y="1115568"/>
             <a:ext cx="10317175" cy="0"/>
           </a:xfrm>
           <a:prstGeom prst="line">
@@ -3348,7 +3348,7 @@
                           <a:ea typeface="Calibri" pitchFamily="34" charset="-122"/>
                           <a:cs typeface="Calibri" pitchFamily="34" charset="-120"/>
                         </a:rPr>
-                        <a:t>ЕС (Директива 2013/59/Евратом) [13]</a:t>
+                        <a:t>ЕС (Директива 2013/59/Евратом) [12]</a:t>
                       </a:r>
                       <a:endParaRPr lang="ru-RU" sz="1800" dirty="0">
                         <a:latin typeface="Calibri" charset="0"/>
@@ -3416,7 +3416,7 @@
                           <a:ea typeface="Calibri" pitchFamily="34" charset="-122"/>
                           <a:cs typeface="Calibri" pitchFamily="34" charset="-120"/>
                         </a:rPr>
-                        <a:t>Германия [14, 15]</a:t>
+                        <a:t>Германия [13, 14]</a:t>
                       </a:r>
                       <a:endParaRPr lang="ru-RU" sz="1800" dirty="0">
                         <a:latin typeface="Calibri" charset="0"/>
@@ -5630,25 +5630,6 @@
                   <a:schemeClr val="tx1"/>
                 </a:solidFill>
               </a:rPr>
-              <a:t>Громова Н. Ю., Шутов Н. Р. Исследование радиационного фона на борту воздушного судна в различных фазах полета и его влияние на радиационную безопасность летного состава : рукопись. – Ульяновск, 2026.</a:t>
-            </a:r>
-            <a:endParaRPr lang="ru-RU" sz="1400" dirty="0"/>
-          </a:p>
-          <a:p>
-            <a:pPr algn="just" marL="342900" indent="-342900">
-              <a:spcAft>
-                <a:spcPts val="400"/>
-              </a:spcAft>
-              <a:buSzPct val="100000"/>
-              <a:buFont typeface="+mj-lt"/>
-              <a:buAutoNum type="arabicPeriod" startAt="1"/>
-            </a:pPr>
-            <a:r>
-              <a:rPr lang="ru-RU" altLang="en-US" sz="1400" dirty="0">
-                <a:solidFill>
-                  <a:schemeClr val="tx1"/>
-                </a:solidFill>
-              </a:rPr>
               <a:t>ICRP Publication 132. Radiological Protection from Cosmic Radiation in Aviation // Annals of the ICRP. – 2016. – Vol. 45, № 1.</a:t>
             </a:r>
             <a:endParaRPr lang="ru-RU" sz="1400" dirty="0"/>
@@ -5904,7 +5885,7 @@
               </a:spcAft>
               <a:buSzPct val="100000"/>
               <a:buFont typeface="+mj-lt"/>
-              <a:buAutoNum type="arabicPeriod" startAt="9"/>
+              <a:buAutoNum type="arabicPeriod" startAt="8"/>
             </a:pPr>
             <a:r>
               <a:rPr lang="ru-RU" altLang="en-US" sz="1400" dirty="0">
@@ -5923,7 +5904,7 @@
               </a:spcAft>
               <a:buSzPct val="100000"/>
               <a:buFont typeface="+mj-lt"/>
-              <a:buAutoNum type="arabicPeriod" startAt="9"/>
+              <a:buAutoNum type="arabicPeriod" startAt="8"/>
             </a:pPr>
             <a:r>
               <a:rPr lang="ru-RU" altLang="en-US" sz="1400" dirty="0">
@@ -5942,7 +5923,7 @@
               </a:spcAft>
               <a:buSzPct val="100000"/>
               <a:buFont typeface="+mj-lt"/>
-              <a:buAutoNum type="arabicPeriod" startAt="9"/>
+              <a:buAutoNum type="arabicPeriod" startAt="8"/>
             </a:pPr>
             <a:r>
               <a:rPr lang="ru-RU" altLang="en-US" sz="1400" dirty="0">
@@ -5961,7 +5942,7 @@
               </a:spcAft>
               <a:buSzPct val="100000"/>
               <a:buFont typeface="+mj-lt"/>
-              <a:buAutoNum type="arabicPeriod" startAt="9"/>
+              <a:buAutoNum type="arabicPeriod" startAt="8"/>
             </a:pPr>
             <a:r>
               <a:rPr lang="ru-RU" altLang="en-US" sz="1400" dirty="0">
@@ -5980,7 +5961,7 @@
               </a:spcAft>
               <a:buSzPct val="100000"/>
               <a:buFont typeface="+mj-lt"/>
-              <a:buAutoNum type="arabicPeriod" startAt="9"/>
+              <a:buAutoNum type="arabicPeriod" startAt="8"/>
             </a:pPr>
             <a:r>
               <a:rPr lang="ru-RU" altLang="en-US" sz="1400" dirty="0">
@@ -5999,7 +5980,7 @@
               </a:spcAft>
               <a:buSzPct val="100000"/>
               <a:buFont typeface="+mj-lt"/>
-              <a:buAutoNum type="arabicPeriod" startAt="9"/>
+              <a:buAutoNum type="arabicPeriod" startAt="8"/>
             </a:pPr>
             <a:r>
               <a:rPr lang="ru-RU" altLang="en-US" sz="1400" dirty="0">
@@ -6018,7 +5999,7 @@
               </a:spcAft>
               <a:buSzPct val="100000"/>
               <a:buFont typeface="+mj-lt"/>
-              <a:buAutoNum type="arabicPeriod" startAt="9"/>
+              <a:buAutoNum type="arabicPeriod" startAt="8"/>
             </a:pPr>
             <a:r>
               <a:rPr lang="ru-RU" altLang="en-US" sz="1400" dirty="0">
@@ -6300,7 +6281,7 @@
                   <a:schemeClr val="tx1"/>
                 </a:solidFill>
               </a:rPr>
-              <a:t>На эшелоне радиационный фон в 11–⁠22 раза выше, чем у земли [1]</a:t>
+              <a:t>На эшелоне радиационный фон в 11–⁠22 раза выше, чем у земли (по нашим измерениям)</a:t>
             </a:r>
             <a:endParaRPr lang="ru-RU" sz="2400" dirty="0"/>
           </a:p>
@@ -6318,7 +6299,7 @@
                   <a:schemeClr val="tx1"/>
                 </a:solidFill>
               </a:rPr>
-              <a:t>С 1990 года МКРЗ относит облучение экипажей к профессиональному [2]</a:t>
+              <a:t>С 1990 года МКРЗ относит облучение экипажей к профессиональному [1]</a:t>
             </a:r>
             <a:endParaRPr lang="ru-RU" sz="2400" dirty="0"/>
           </a:p>
@@ -6336,7 +6317,7 @@
                   <a:schemeClr val="tx1"/>
                 </a:solidFill>
               </a:rPr>
-              <a:t>Специальные санитарные правила об облучении экипажей утратили силу в 2021 и 2025 годах [8, 9]</a:t>
+              <a:t>Специальные санитарные правила об облучении экипажей утратили силу в 2021 и 2025 годах [7, 8]</a:t>
             </a:r>
             <a:endParaRPr lang="ru-RU" sz="2400" dirty="0"/>
           </a:p>
@@ -6354,7 +6335,7 @@
                   <a:schemeClr val="tx1"/>
                 </a:solidFill>
               </a:rPr>
-              <a:t>По модельной оценке, при налёте 900 часов в год доза может составить около 3,6 мЗв – более 70 % предела [3]</a:t>
+              <a:t>По модельной оценке, при налёте 900 часов в год доза может составить около 3,6 мЗв – более 70 % предела [2]</a:t>
             </a:r>
             <a:endParaRPr lang="ru-RU" sz="2400" dirty="0"/>
           </a:p>
@@ -6495,7 +6476,7 @@
         <p:spPr>
           <a:xfrm>
             <a:off x="548640" y="1371600"/>
-            <a:ext cx="11094415" cy="1828800"/>
+            <a:ext cx="11094415" cy="2194560"/>
           </a:xfrm>
           <a:prstGeom prst="rect">
             <a:avLst/>
@@ -6578,7 +6559,7 @@
         </p:nvSpPr>
         <p:spPr>
           <a:xfrm>
-            <a:off x="548640" y="3337560"/>
+            <a:off x="548640" y="3611880"/>
             <a:ext cx="11094415" cy="411480"/>
           </a:xfrm>
           <a:prstGeom prst="rect">
@@ -6614,8 +6595,8 @@
         </p:nvSpPr>
         <p:spPr>
           <a:xfrm>
-            <a:off x="548640" y="3794760"/>
-            <a:ext cx="11094415" cy="2468880"/>
+            <a:off x="548640" y="4069080"/>
+            <a:ext cx="11094415" cy="2240280"/>
           </a:xfrm>
           <a:prstGeom prst="rect">
             <a:avLst/>
@@ -6842,7 +6823,7 @@
                   <a:schemeClr val="tx1"/>
                 </a:solidFill>
               </a:rPr>
-              <a:t>Таблица 1 – Показания дозиметра на этапах полёта [1]</a:t>
+              <a:t>Таблица 1 – Показания дозиметра на этапах полёта</a:t>
             </a:r>
             <a:endParaRPr lang="ru-RU" sz="2000" dirty="0"/>
           </a:p>
@@ -7098,7 +7079,7 @@
                           <a:ea typeface="Calibri" pitchFamily="34" charset="-122"/>
                           <a:cs typeface="Calibri" pitchFamily="34" charset="-120"/>
                         </a:rPr>
-                        <a:t>Показания, мкР/ч</a:t>
+                        <a:t>Средние показания, мкР/ч</a:t>
                       </a:r>
                       <a:endParaRPr lang="ru-RU" sz="1800" dirty="0">
                         <a:latin typeface="Calibri" charset="0"/>
@@ -8832,7 +8813,7 @@
                   <a:schemeClr val="tx1"/>
                 </a:solidFill>
               </a:rPr>
-              <a:t>поэтому годовую дозу определяют расчётом по маршрутам и времени полёта [3]</a:t>
+              <a:t>поэтому годовую дозу определяют расчётом по маршрутам и времени полёта [2]</a:t>
             </a:r>
             <a:endParaRPr lang="ru-RU" sz="2200" dirty="0"/>
           </a:p>
@@ -9216,7 +9197,7 @@
                   <a:schemeClr val="tx1"/>
                 </a:solidFill>
               </a:rPr>
-              <a:t>Рисунок 1 – Показания дозиметра: а – перед взлётом (13,2 мкР/ч); б – на эшелоне FL350 (194,8 мкР/ч); в – после посадки (9,9 мкР/ч); г – точка NILRA на пилотажном дисплее</a:t>
+              <a:t>Рисунок 1 – Текущие показания дозиметра: а – перед взлётом (13,2 мкР/ч); б – на эшелоне FL350 (194,8 мкР/ч); в – после посадки (9,9 мкР/ч); г – точка NILRA на пилотажном дисплее</a:t>
             </a:r>
             <a:endParaRPr lang="ru-RU" sz="1600" dirty="0"/>
           </a:p>
@@ -10216,9 +10197,9 @@
             <a:tbl>
               <a:tblPr/>
               <a:tblGrid>
-                <a:gridCol w="3749040"/>
-                <a:gridCol w="4572000"/>
-                <a:gridCol w="2770632"/>
+                <a:gridCol w="4251960"/>
+                <a:gridCol w="4526280"/>
+                <a:gridCol w="2313432"/>
               </a:tblGrid>
               <a:tr h="0">
                 <a:tc>
@@ -10574,7 +10555,7 @@
                           <a:ea typeface="Calibri" pitchFamily="34" charset="-122"/>
                           <a:cs typeface="Calibri" pitchFamily="34" charset="-120"/>
                         </a:rPr>
-                        <a:t>утратил силу с 01.01.2021 [8]</a:t>
+                        <a:t>утратил силу с 01.01.2021 [7]</a:t>
                       </a:r>
                       <a:endParaRPr lang="ru-RU" sz="2000" dirty="0">
                         <a:latin typeface="Calibri" charset="0"/>
@@ -10777,7 +10758,7 @@
                           <a:ea typeface="Calibri" pitchFamily="34" charset="-122"/>
                           <a:cs typeface="Calibri" pitchFamily="34" charset="-120"/>
                         </a:rPr>
-                        <a:t>утратил силу с 01.09.2025 [9]</a:t>
+                        <a:t>утратил силу с 01.09.2025 [8]</a:t>
                       </a:r>
                       <a:endParaRPr lang="ru-RU" sz="2000" dirty="0">
                         <a:latin typeface="Calibri" charset="0"/>
@@ -10977,7 +10958,7 @@
                           <a:ea typeface="Calibri" pitchFamily="34" charset="-122"/>
                           <a:cs typeface="Calibri" pitchFamily="34" charset="-120"/>
                         </a:rPr>
-                        <a:t>действует [6]</a:t>
+                        <a:t>действует [5]</a:t>
                       </a:r>
                       <a:endParaRPr lang="ru-RU" sz="2000" dirty="0">
                         <a:latin typeface="Calibri" charset="0"/>
@@ -11246,7 +11227,7 @@
                   <a:schemeClr val="tx1"/>
                 </a:solidFill>
               </a:rPr>
-              <a:t>Не обнаружен порядок передачи доз экипажей в ЕСКИД, хотя ст. 18 закона № 3‑ФЗ требует учёта доз [4]</a:t>
+              <a:t>Не обнаружен порядок передачи доз экипажей в ЕСКИД, хотя ст. 18 закона № 3‑ФЗ требует учёта доз [3]</a:t>
             </a:r>
             <a:endParaRPr lang="ru-RU" sz="2400" dirty="0"/>
           </a:p>
@@ -11414,7 +11395,7 @@
                   <a:schemeClr val="tx1"/>
                 </a:solidFill>
               </a:rPr>
-              <a:t>СОУТ проводится в одном контрольном полёте и не отражает годовую дозу на разных маршрутах [11]</a:t>
+              <a:t>СОУТ проводится в одном контрольном полёте и не отражает годовую дозу на разных маршрутах [10]</a:t>
             </a:r>
             <a:endParaRPr lang="ru-RU" sz="2400" dirty="0"/>
           </a:p>
@@ -11432,7 +11413,7 @@
                   <a:schemeClr val="tx1"/>
                 </a:solidFill>
               </a:rPr>
-              <a:t>Лимиты налёта (800 ч, с согласия – 900 ч в год) не учитывают дозу; согласие даётся без знания своей дозы [12]</a:t>
+              <a:t>Лимиты налёта (800 ч, с согласия – 900 ч в год) не учитывают дозу; согласие даётся без знания своей дозы [11]</a:t>
             </a:r>
             <a:endParaRPr lang="ru-RU" sz="2400" dirty="0"/>
           </a:p>

</xml_diff>